<commit_message>
deck: sharpen Audit-as-a-Service into a single crisp wedge (framing only)
- subtitle reframed to the buyer's question: "can this QPU run my workload?"
- offering leads with the wedge (does a given QPU retain signal on the client's
  OWN circuit, before they commit budget) and adds a concrete proof bullet:
  our own program qualified 4 configs signal-bearing / 2 scrambled on the SAME
  circuit — a ~$70 single-device test that pre-empts a six-figure wrong build
- segments restructured from a flat 4-item list into BEACHHEAD (buy-side risk/
  quant desk) + EXPANSION; no fabricated customers/LOIs (honesty note kept)

No new claims; pricing still tied to measured spend. 9 slides; no Capgemini/keys.

Co-Authored-By: Claude Fable 5 <noreply@anthropic.com>
Claude-Session: https://claude.ai/code/session_01SH3wHCzTCUP7HwrV3NZtab
</commit_message>
<xml_diff>
--- a/docs/EIGENNEXUS_CxO_Deck.pptx
+++ b/docs/EIGENNEXUS_CxO_Deck.pptx
@@ -10025,7 +10025,7 @@
                 </a:solidFill>
                 <a:latin typeface="Calibri"/>
               </a:rPr>
-              <a:t>Audit-as-a-Service — vendor-neutral QPU qualification</a:t>
+              <a:t>Audit-as-a-Service — the pre-registered 'can this QPU run my workload?' exam</a:t>
             </a:r>
           </a:p>
         </p:txBody>
@@ -10155,7 +10155,7 @@
                 </a:solidFill>
                 <a:latin typeface="Calibri"/>
               </a:rPr>
-              <a:t>The rigged-to-be-honest exam for a client's own workload:</a:t>
+              <a:t>The wedge — answered with receipts: does a given QPU retain signal on a client's OWN circuit, before they commit budget?</a:t>
             </a:r>
           </a:p>
           <a:p>
@@ -10212,7 +10212,7 @@
                 </a:solidFill>
                 <a:latin typeface="Calibri"/>
               </a:rPr>
-              <a:t>• a report that says what each QPU can and cannot do — with receipts</a:t>
+              <a:t>• a report of what each QPU can and cannot do — every number re-derivable from raw data</a:t>
             </a:r>
           </a:p>
           <a:p>
@@ -10231,7 +10231,7 @@
                 </a:solidFill>
                 <a:latin typeface="Calibri"/>
               </a:rPr>
-              <a:t>• every number re-derivable from raw data; spend audited to the credit</a:t>
+              <a:t>• proof it works: our own program qualified 4 configs signal-bearing, 2 scrambled — on the SAME circuit; a ~$70 single-device test that pre-empts a six-figure wrong build</a:t>
             </a:r>
           </a:p>
         </p:txBody>
@@ -10544,7 +10544,7 @@
                 </a:solidFill>
                 <a:latin typeface="Calibri"/>
               </a:rPr>
-              <a:t>TARGET DESIGN PARTNERS</a:t>
+              <a:t>WHO BUYS FIRST</a:t>
             </a:r>
           </a:p>
         </p:txBody>
@@ -10580,13 +10580,13 @@
               </a:spcAft>
             </a:pPr>
             <a:r>
-              <a:rPr sz="1150" b="0">
+              <a:rPr sz="1150" b="1">
                 <a:solidFill>
                   <a:srgbClr val="A9B4C8"/>
                 </a:solidFill>
                 <a:latin typeface="Calibri"/>
               </a:rPr>
-              <a:t>Buy-side risk / quant desks vetting QPU vendor claims</a:t>
+              <a:t>BEACHHEAD — a buy-side risk / quant desk</a:t>
             </a:r>
           </a:p>
           <a:p>
@@ -10599,13 +10599,13 @@
               </a:spcAft>
             </a:pPr>
             <a:r>
-              <a:rPr sz="1150" b="0">
+              <a:rPr sz="1100" b="0">
                 <a:solidFill>
                   <a:srgbClr val="A9B4C8"/>
                 </a:solidFill>
                 <a:latin typeface="Calibri"/>
               </a:rPr>
-              <a:t>Quantum hardware vendors needing independent benchmarks</a:t>
+              <a:t>about to fund a quantum pilot: we tell them which device (if any) survives THEIR circuit — before they build.</a:t>
             </a:r>
           </a:p>
           <a:p>
@@ -10618,13 +10618,13 @@
               </a:spcAft>
             </a:pPr>
             <a:r>
-              <a:rPr sz="1150" b="0">
+              <a:rPr sz="1150" b="1">
                 <a:solidFill>
                   <a:srgbClr val="A9B4C8"/>
                 </a:solidFill>
                 <a:latin typeface="Calibri"/>
               </a:rPr>
-              <a:t>CTO / innovation offices doing quantum-readiness diligence</a:t>
+              <a:t>EXPANSION</a:t>
             </a:r>
           </a:p>
           <a:p>
@@ -10637,13 +10637,13 @@
               </a:spcAft>
             </a:pPr>
             <a:r>
-              <a:rPr sz="1150" b="0">
+              <a:rPr sz="1100" b="0">
                 <a:solidFill>
                   <a:srgbClr val="A9B4C8"/>
                 </a:solidFill>
                 <a:latin typeface="Calibri"/>
               </a:rPr>
-              <a:t>Public-sector evaluation programs (assurance-grade)</a:t>
+              <a:t>Hardware vendors (independent benchmarks) · CTO quantum-readiness diligence · public-sector assurance.</a:t>
             </a:r>
           </a:p>
         </p:txBody>

</xml_diff>